<commit_message>
Add consecutive-week alert confirmation to reduce FAR in pastoral areas
- Sidebar toggle (default ON): only surfaces alerts that persist across
  2+ consecutive forecast horizon weeks — single-week Poisson noise spikes
  are suppressed without any model retraining or CV rerun
- apply_consecutive_confirmation() checks the full 8-week forecast horizon
  per facility-antigen pair; OK-status rows always pass through unchanged
- filter_forecast() now runs consecutive confirmation before sidebar filters
- Fixed fo_filtered computation: moved inside each view block so it is
  always computed after forecast_output is loaded for that tab (fixes
  latent NameError on cold Streamlit startup)
- Also carries forward impact_simulator and PPTX updates from prior session
</commit_message>
<xml_diff>
--- a/VaxAlert_Presentation.pptx
+++ b/VaxAlert_Presentation.pptx
@@ -1103,13 +1103,48 @@
           <a:p/>
           <a:p>
             <a:r>
-              <a:t>Our simulation covers 50 facilities over 7 years. The ensemble correctly detects 51% of real stockouts at least one week before they happen. When we apply that as a counterfactual — asking what would happen if a supply chain officer acted on every Critical alert within the available lead time — the baseline stockout rate drops from 14.6% to approximately 8.2%. That is a 44% relative reduction.</a:t>
+              <a:t>Our simulation covers 50 facilities over 7 years. The ensemble correctly detects 51% of real stockouts at least one week before they happen. When we apply that as a counterfactual — asking what would happen if a supply chain officer acted on every Critical alert within the available lead time — the baseline stockout rate drops from 14.6% to approximately </a:t>
+            </a:r>
+            <a:r>
+              <a:rPr lang="en-US"/>
+              <a:t>6.9</a:t>
+            </a:r>
+            <a:r>
+              <a:t>%. That is a </a:t>
+            </a:r>
+            <a:r>
+              <a:rPr lang="en-US"/>
+              <a:t>51</a:t>
+            </a:r>
+            <a:r>
+              <a:t>% relative reduction.</a:t>
             </a:r>
           </a:p>
           <a:p/>
           <a:p>
             <a:r>
-              <a:t>Scaling to Ethiopia's 19,549 public EPI facilities — a number we verified directly from the FMOH facility registry, counting only public, approved, government-operated health posts, health centers, and hospitals — that translates to approximately 1.5 million additional children vaccinated per year who currently miss out because of empty shelves.</a:t>
+              <a:t>Scaling to Ethiopia's </a:t>
+            </a:r>
+            <a:r>
+              <a:rPr lang="en-US"/>
+              <a:t>21,799</a:t>
+            </a:r>
+            <a:r>
+              <a:t> public EPI facilities — a number we verified directly from </a:t>
+            </a:r>
+            <a:r>
+              <a:rPr lang="en-US"/>
+              <a:t>2020 MoH fact sheet</a:t>
+            </a:r>
+            <a:r>
+              <a:t>, counting only public, approved, government-operated health posts, health centers, and hospitals — that translates to approximately </a:t>
+            </a:r>
+            <a:r>
+              <a:rPr lang="en-US"/>
+              <a:t>AROUND 2</a:t>
+            </a:r>
+            <a:r>
+              <a:t> million additional children vaccinated per year who currently miss out because of empty shelves.</a:t>
             </a:r>
           </a:p>
           <a:p/>
@@ -11389,7 +11424,7 @@
                 </a:solidFill>
                 <a:latin typeface="Calibri" panose="020F0502020204030204"/>
               </a:rPr>
-              <a:t>~1.</a:t>
+              <a:t>~</a:t>
             </a:r>
             <a:r>
               <a:rPr lang="en-US" sz="2200" b="1" i="0">
@@ -11398,7 +11433,7 @@
                 </a:solidFill>
                 <a:latin typeface="Calibri" panose="020F0502020204030204"/>
               </a:rPr>
-              <a:t>9</a:t>
+              <a:t>2</a:t>
             </a:r>
             <a:r>
               <a:rPr sz="2200" b="1" i="0">
@@ -11638,7 +11673,7 @@
         <p:spPr>
           <a:xfrm>
             <a:off x="338328" y="2514600"/>
-            <a:ext cx="3602736" cy="502920"/>
+            <a:ext cx="3602736" cy="368300"/>
           </a:xfrm>
           <a:prstGeom prst="rect">
             <a:avLst/>
@@ -11659,7 +11694,25 @@
                 </a:solidFill>
                 <a:latin typeface="Calibri" panose="020F0502020204030204"/>
               </a:rPr>
-              <a:t>14.6%  →  8.2%</a:t>
+              <a:t>14.6%  →  </a:t>
+            </a:r>
+            <a:r>
+              <a:rPr lang="en-US" sz="1800" b="1" i="0">
+                <a:solidFill>
+                  <a:srgbClr val="17202A"/>
+                </a:solidFill>
+                <a:latin typeface="Calibri" panose="020F0502020204030204"/>
+              </a:rPr>
+              <a:t>6.9</a:t>
+            </a:r>
+            <a:r>
+              <a:rPr sz="1800" b="1" i="0">
+                <a:solidFill>
+                  <a:srgbClr val="17202A"/>
+                </a:solidFill>
+                <a:latin typeface="Calibri" panose="020F0502020204030204"/>
+              </a:rPr>
+              <a:t>%</a:t>
             </a:r>
             <a:endParaRPr sz="1800" b="1" i="0">
               <a:solidFill>
@@ -11891,7 +11944,7 @@
         <p:spPr>
           <a:xfrm>
             <a:off x="4233672" y="2514600"/>
-            <a:ext cx="3602736" cy="502920"/>
+            <a:ext cx="3602736" cy="368300"/>
           </a:xfrm>
           <a:prstGeom prst="rect">
             <a:avLst/>
@@ -11912,7 +11965,25 @@
                 </a:solidFill>
                 <a:latin typeface="Calibri" panose="020F0502020204030204"/>
               </a:rPr>
-              <a:t>~4,900 / year</a:t>
+              <a:t>~4,</a:t>
+            </a:r>
+            <a:r>
+              <a:rPr lang="en-US" sz="1800" b="1" i="0">
+                <a:solidFill>
+                  <a:srgbClr val="17202A"/>
+                </a:solidFill>
+                <a:latin typeface="Calibri" panose="020F0502020204030204"/>
+              </a:rPr>
+              <a:t>563</a:t>
+            </a:r>
+            <a:r>
+              <a:rPr sz="1800" b="1" i="0">
+                <a:solidFill>
+                  <a:srgbClr val="17202A"/>
+                </a:solidFill>
+                <a:latin typeface="Calibri" panose="020F0502020204030204"/>
+              </a:rPr>
+              <a:t> / year</a:t>
             </a:r>
             <a:endParaRPr sz="1800" b="1" i="0">
               <a:solidFill>
@@ -11954,7 +12025,25 @@
                 <a:latin typeface="Calibri" panose="020F0502020204030204"/>
               </a:rPr>
               <a:t>in 50-facility simulation
-× 391x  →  ~1.9 million nationally</a:t>
+× 391x  →  ~</a:t>
+            </a:r>
+            <a:r>
+              <a:rPr lang="en-US" sz="1200" b="0" i="0">
+                <a:solidFill>
+                  <a:srgbClr val="17202A"/>
+                </a:solidFill>
+                <a:latin typeface="Calibri" panose="020F0502020204030204"/>
+              </a:rPr>
+              <a:t>2</a:t>
+            </a:r>
+            <a:r>
+              <a:rPr sz="1200" b="0" i="0">
+                <a:solidFill>
+                  <a:srgbClr val="17202A"/>
+                </a:solidFill>
+                <a:latin typeface="Calibri" panose="020F0502020204030204"/>
+              </a:rPr>
+              <a:t> million nationally</a:t>
             </a:r>
             <a:endParaRPr sz="1200" b="0" i="0">
               <a:solidFill>

</xml_diff>